<commit_message>
Algo & subsequent PPTX Update
Improve solver: score candidates by per-position letter frequency instead of global frequency; override greedy pick with a diagnostic guess when multiple words share scores remain to better distinguish between them.
</commit_message>
<xml_diff>
--- a/Wordle_HillClimbing.pptx
+++ b/Wordle_HillClimbing.pptx
@@ -155,7 +155,17 @@
     </c:title>
     <c:autoTitleDeleted val="0"/>
     <c:plotArea>
-      <c:layout/>
+      <c:layout>
+        <c:manualLayout>
+          <c:layoutTarget val="inner"/>
+          <c:xMode val="edge"/>
+          <c:yMode val="edge"/>
+          <c:x val="0.10423096358644826"/>
+          <c:y val="0.11333695756099491"/>
+          <c:w val="0.86942804024496934"/>
+          <c:h val="0.80035035869341586"/>
+        </c:manualLayout>
+      </c:layout>
       <c:barChart>
         <c:barDir val="col"/>
         <c:grouping val="clustered"/>
@@ -169,7 +179,7 @@
               <c:strCache>
                 <c:ptCount val="1"/>
                 <c:pt idx="0">
-                  <c:v>Hill Climbing</c:v>
+                  <c:v>Our Bot</c:v>
                 </c:pt>
               </c:strCache>
             </c:strRef>
@@ -181,43 +191,6 @@
             <a:effectLst/>
           </c:spPr>
           <c:invertIfNegative val="0"/>
-          <c:dLbls>
-            <c:numFmt formatCode="#,##0" sourceLinked="0"/>
-            <c:spPr>
-              <a:noFill/>
-              <a:ln>
-                <a:noFill/>
-              </a:ln>
-              <a:effectLst/>
-            </c:spPr>
-            <c:txPr>
-              <a:bodyPr/>
-              <a:lstStyle/>
-              <a:p>
-                <a:pPr>
-                  <a:defRPr sz="1200" b="0" i="0" u="none" strike="noStrike">
-                    <a:solidFill>
-                      <a:srgbClr val="334155"/>
-                    </a:solidFill>
-                    <a:latin typeface="Arial"/>
-                  </a:defRPr>
-                </a:pPr>
-                <a:endParaRPr lang="en-US"/>
-              </a:p>
-            </c:txPr>
-            <c:showLegendKey val="0"/>
-            <c:showVal val="1"/>
-            <c:showCatName val="0"/>
-            <c:showSerName val="0"/>
-            <c:showPercent val="0"/>
-            <c:showBubbleSize val="0"/>
-            <c:showLeaderLines val="0"/>
-            <c:extLst>
-              <c:ext xmlns:c15="http://schemas.microsoft.com/office/drawing/2012/chart" uri="{CE6537A1-D6FC-4f65-9D91-7224C49458BB}">
-                <c15:showLeaderLines val="0"/>
-              </c:ext>
-            </c:extLst>
-          </c:dLbls>
           <c:cat>
             <c:strRef>
               <c:f>Sheet1!$A$2:$A$8</c:f>
@@ -257,22 +230,22 @@
                   <c:v>1</c:v>
                 </c:pt>
                 <c:pt idx="1">
-                  <c:v>130</c:v>
+                  <c:v>145</c:v>
                 </c:pt>
                 <c:pt idx="2">
-                  <c:v>920</c:v>
+                  <c:v>878</c:v>
                 </c:pt>
                 <c:pt idx="3">
-                  <c:v>921</c:v>
+                  <c:v>1011</c:v>
                 </c:pt>
                 <c:pt idx="4">
-                  <c:v>268</c:v>
+                  <c:v>254</c:v>
                 </c:pt>
                 <c:pt idx="5">
-                  <c:v>53</c:v>
+                  <c:v>26</c:v>
                 </c:pt>
                 <c:pt idx="6">
-                  <c:v>22</c:v>
+                  <c:v>0</c:v>
                 </c:pt>
               </c:numCache>
             </c:numRef>
@@ -283,9 +256,89 @@
             </c:ext>
           </c:extLst>
         </c:ser>
+        <c:ser>
+          <c:idx val="1"/>
+          <c:order val="1"/>
+          <c:tx>
+            <c:strRef>
+              <c:f>Sheet1!$C$1</c:f>
+              <c:strCache>
+                <c:ptCount val="1"/>
+                <c:pt idx="0">
+                  <c:v>Avg Human</c:v>
+                </c:pt>
+              </c:strCache>
+            </c:strRef>
+          </c:tx>
+          <c:invertIfNegative val="0"/>
+          <c:cat>
+            <c:strRef>
+              <c:f>Sheet1!$A$2:$A$8</c:f>
+              <c:strCache>
+                <c:ptCount val="7"/>
+                <c:pt idx="0">
+                  <c:v>1 turn</c:v>
+                </c:pt>
+                <c:pt idx="1">
+                  <c:v>2 turns</c:v>
+                </c:pt>
+                <c:pt idx="2">
+                  <c:v>3 turns</c:v>
+                </c:pt>
+                <c:pt idx="3">
+                  <c:v>4 turns</c:v>
+                </c:pt>
+                <c:pt idx="4">
+                  <c:v>5 turns</c:v>
+                </c:pt>
+                <c:pt idx="5">
+                  <c:v>6 turns</c:v>
+                </c:pt>
+                <c:pt idx="6">
+                  <c:v>Failed</c:v>
+                </c:pt>
+              </c:strCache>
+            </c:strRef>
+          </c:cat>
+          <c:val>
+            <c:numRef>
+              <c:f>Sheet1!$C$2:$C$8</c:f>
+              <c:numCache>
+                <c:formatCode>General</c:formatCode>
+                <c:ptCount val="7"/>
+                <c:pt idx="0">
+                  <c:v>9</c:v>
+                </c:pt>
+                <c:pt idx="1">
+                  <c:v>243</c:v>
+                </c:pt>
+                <c:pt idx="2">
+                  <c:v>718</c:v>
+                </c:pt>
+                <c:pt idx="3">
+                  <c:v>778</c:v>
+                </c:pt>
+                <c:pt idx="4">
+                  <c:v>370</c:v>
+                </c:pt>
+                <c:pt idx="5">
+                  <c:v>162</c:v>
+                </c:pt>
+                <c:pt idx="6">
+                  <c:v>35</c:v>
+                </c:pt>
+              </c:numCache>
+            </c:numRef>
+          </c:val>
+          <c:extLst>
+            <c:ext xmlns:c16="http://schemas.microsoft.com/office/drawing/2014/chart" uri="{C3380CC4-5D6E-409C-BE32-E72D297353CC}">
+              <c16:uniqueId val="{00000000-76DD-447F-918D-8ED52EC3E0C9}"/>
+            </c:ext>
+          </c:extLst>
+        </c:ser>
         <c:dLbls>
           <c:showLegendKey val="0"/>
-          <c:showVal val="1"/>
+          <c:showVal val="0"/>
           <c:showCatName val="0"/>
           <c:showSerName val="0"/>
           <c:showPercent val="0"/>
@@ -395,6 +448,10 @@
         <a:effectLst/>
       </c:spPr>
     </c:plotArea>
+    <c:legend>
+      <c:legendPos val="r"/>
+      <c:overlay val="0"/>
+    </c:legend>
     <c:plotVisOnly val="1"/>
     <c:dispBlanksAs val="span"/>
     <c:showDLblsOverMax val="1"/>
@@ -2067,7 +2124,7 @@
                 <a:ea typeface="Georgia" pitchFamily="34" charset="-122"/>
                 <a:cs typeface="Georgia" pitchFamily="34" charset="-120"/>
               </a:rPr>
-              <a:t>Human vs Hill Climbing</a:t>
+              <a:t>Human vs Bot</a:t>
             </a:r>
             <a:endParaRPr lang="en-US" sz="2800" dirty="0"/>
           </a:p>
@@ -2328,7 +2385,7 @@
         <p:spPr>
           <a:xfrm>
             <a:off x="274320" y="960120"/>
-            <a:ext cx="5120640" cy="3657600"/>
+            <a:ext cx="5120640" cy="3807324"/>
           </a:xfrm>
           <a:prstGeom prst="rect">
             <a:avLst/>
@@ -2600,8 +2657,8 @@
         </p:nvSpPr>
         <p:spPr>
           <a:xfrm>
-            <a:off x="5669280" y="960120"/>
-            <a:ext cx="3108960" cy="3657600"/>
+            <a:off x="5669280" y="960119"/>
+            <a:ext cx="3108960" cy="3807325"/>
           </a:xfrm>
           <a:prstGeom prst="rect">
             <a:avLst/>
@@ -5210,7 +5267,7 @@
                 <a:ea typeface="Calibri" pitchFamily="34" charset="-122"/>
                 <a:cs typeface="Calibri" pitchFamily="34" charset="-120"/>
               </a:rPr>
-              <a:t>Calculate letter frequencies from (remaining) words in the list.</a:t>
+              <a:t>Calculate letter frequencies &amp; positions of the (remaining) wordlist.</a:t>
             </a:r>
             <a:endParaRPr lang="en-US" sz="1150" dirty="0"/>
           </a:p>
@@ -5395,7 +5452,7 @@
                 <a:ea typeface="Calibri" pitchFamily="34" charset="-122"/>
                 <a:cs typeface="Calibri" pitchFamily="34" charset="-120"/>
               </a:rPr>
-              <a:t>Score each word by summing unique-letter frequencies.</a:t>
+              <a:t>Score each word by summing unique-letter-position frequencies.</a:t>
             </a:r>
             <a:endParaRPr lang="en-US" sz="1150" dirty="0"/>
           </a:p>
@@ -5577,7 +5634,7 @@
                 <a:ea typeface="Calibri" pitchFamily="34" charset="-122"/>
                 <a:cs typeface="Calibri" pitchFamily="34" charset="-120"/>
               </a:rPr>
-              <a:t>Select highest-scoring word, with tie-breaks done alphabetically.</a:t>
+              <a:t>Select highest-scoring word, with tie-breaks done alphabetically or with distinguishing letters.</a:t>
             </a:r>
             <a:endParaRPr lang="en-US" sz="1150" dirty="0"/>
           </a:p>
@@ -5762,7 +5819,7 @@
                 <a:ea typeface="Calibri" pitchFamily="34" charset="-122"/>
                 <a:cs typeface="Calibri" pitchFamily="34" charset="-120"/>
               </a:rPr>
-              <a:t>Eliminate candidates that the word cannot possibly be.</a:t>
+              <a:t>Eliminate candidates that the word cannot possibly be (CSP Aspect).</a:t>
             </a:r>
             <a:endParaRPr lang="en-US" sz="1150" dirty="0"/>
           </a:p>
@@ -5978,14 +6035,41 @@
               <a:buNone/>
             </a:pPr>
             <a:r>
-              <a:rPr lang="en-US" sz="2000" i="1" dirty="0">
+              <a:rPr lang="en-US" b="1" i="1" dirty="0">
                 <a:latin typeface="Georgia" panose="02040502050405020303" pitchFamily="18" charset="0"/>
                 <a:ea typeface="Calibri" pitchFamily="34" charset="-122"/>
                 <a:cs typeface="Calibri" pitchFamily="34" charset="-120"/>
               </a:rPr>
-              <a:t>Hill Climbing: always pick the locally optimal next guess</a:t>
-            </a:r>
-            <a:endParaRPr lang="en-US" sz="2000" dirty="0">
+              <a:t>Hill Climbing: </a:t>
+            </a:r>
+            <a:r>
+              <a:rPr lang="en-US" i="1" dirty="0">
+                <a:latin typeface="Georgia" panose="02040502050405020303" pitchFamily="18" charset="0"/>
+                <a:ea typeface="Calibri" pitchFamily="34" charset="-122"/>
+                <a:cs typeface="Calibri" pitchFamily="34" charset="-120"/>
+              </a:rPr>
+              <a:t>always pick the locally optimal next guess</a:t>
+            </a:r>
+          </a:p>
+          <a:p>
+            <a:pPr marL="0" indent="0" algn="ctr">
+              <a:buNone/>
+            </a:pPr>
+            <a:r>
+              <a:rPr lang="en-US" b="1" i="1" dirty="0">
+                <a:latin typeface="Georgia" panose="02040502050405020303" pitchFamily="18" charset="0"/>
+                <a:cs typeface="Calibri" pitchFamily="34" charset="-120"/>
+              </a:rPr>
+              <a:t>Constraint Propagation: </a:t>
+            </a:r>
+            <a:r>
+              <a:rPr lang="en-US" i="1" dirty="0">
+                <a:latin typeface="Georgia" panose="02040502050405020303" pitchFamily="18" charset="0"/>
+                <a:cs typeface="Calibri" pitchFamily="34" charset="-120"/>
+              </a:rPr>
+              <a:t>iteratively reduces the search space in CSPs</a:t>
+            </a:r>
+            <a:endParaRPr lang="en-US" dirty="0">
               <a:latin typeface="Georgia" panose="02040502050405020303" pitchFamily="18" charset="0"/>
             </a:endParaRPr>
           </a:p>
@@ -6136,7 +6220,7 @@
         <p:spPr>
           <a:xfrm>
             <a:off x="274320" y="960120"/>
-            <a:ext cx="4206240" cy="1783080"/>
+            <a:ext cx="4050792" cy="1783080"/>
           </a:xfrm>
           <a:prstGeom prst="rect">
             <a:avLst/>
@@ -6175,7 +6259,7 @@
         <p:spPr>
           <a:xfrm>
             <a:off x="438912" y="1069848"/>
-            <a:ext cx="3886200" cy="411480"/>
+            <a:ext cx="3742580" cy="411480"/>
           </a:xfrm>
           <a:prstGeom prst="rect">
             <a:avLst/>
@@ -6214,7 +6298,7 @@
         <p:spPr>
           <a:xfrm>
             <a:off x="438912" y="1490472"/>
-            <a:ext cx="3886200" cy="1115568"/>
+            <a:ext cx="3742580" cy="1115568"/>
           </a:xfrm>
           <a:prstGeom prst="rect">
             <a:avLst/>
@@ -6238,7 +6322,7 @@
                 <a:ea typeface="Calibri" pitchFamily="34" charset="-122"/>
                 <a:cs typeface="Calibri" pitchFamily="34" charset="-120"/>
               </a:rPr>
-              <a:t>A two-pass algorithm that checks greens first, tallies the rest of the letters, and performs a second pass, making sure not the repeat letters</a:t>
+              <a:t>Replicates Wordle’s feedback using a two-pass algorithm that checks greens first, tallies the rest of the letters, and performs a second pass, making sure not the repeat letters</a:t>
             </a:r>
           </a:p>
         </p:txBody>
@@ -6251,8 +6335,8 @@
         </p:nvSpPr>
         <p:spPr>
           <a:xfrm>
-            <a:off x="4846320" y="960120"/>
-            <a:ext cx="4206240" cy="1783080"/>
+            <a:off x="4572000" y="960120"/>
+            <a:ext cx="4480560" cy="1783080"/>
           </a:xfrm>
           <a:prstGeom prst="rect">
             <a:avLst/>
@@ -6290,8 +6374,8 @@
         </p:nvSpPr>
         <p:spPr>
           <a:xfrm>
-            <a:off x="5010912" y="1069848"/>
-            <a:ext cx="3886200" cy="411480"/>
+            <a:off x="4757464" y="1069848"/>
+            <a:ext cx="4139648" cy="411480"/>
           </a:xfrm>
           <a:prstGeom prst="rect">
             <a:avLst/>
@@ -6329,8 +6413,8 @@
         </p:nvSpPr>
         <p:spPr>
           <a:xfrm>
-            <a:off x="5010912" y="1490472"/>
-            <a:ext cx="3886200" cy="1115568"/>
+            <a:off x="4757464" y="1490472"/>
+            <a:ext cx="4139648" cy="1115568"/>
           </a:xfrm>
           <a:prstGeom prst="rect">
             <a:avLst/>
@@ -6342,9 +6426,6 @@
           <a:bodyPr wrap="square" rtlCol="0" anchor="ctr"/>
           <a:lstStyle/>
           <a:p>
-            <a:pPr marL="0" indent="0">
-              <a:buNone/>
-            </a:pPr>
             <a:r>
               <a:rPr lang="en-US" sz="1150" dirty="0">
                 <a:solidFill>
@@ -6354,7 +6435,7 @@
                 <a:ea typeface="Calibri" pitchFamily="34" charset="-122"/>
                 <a:cs typeface="Calibri" pitchFamily="34" charset="-120"/>
               </a:rPr>
-              <a:t>Words are scored without counting repeated letters, giving words without repeated letters more points, incentivizing the AI to choose words that will give it more information.</a:t>
+              <a:t>Words are scored using positional frequencies; each letter's score depends on how common it is at that specific position in the remaining candidate pool, not just globally. This pushes the AI to choose words that will give it more information.</a:t>
             </a:r>
           </a:p>
         </p:txBody>
@@ -6459,42 +6540,32 @@
           <a:lstStyle/>
           <a:p>
             <a:r>
-              <a:rPr lang="en-US" sz="1150" b="1" dirty="0"/>
+              <a:rPr lang="en-US" sz="1200" b="1" dirty="0"/>
               <a:t>Goal: </a:t>
             </a:r>
             <a:r>
-              <a:rPr lang="en-US" sz="1150" dirty="0"/>
+              <a:rPr lang="en-US" sz="1200" dirty="0"/>
               <a:t>Where the Guess = Secret Word</a:t>
             </a:r>
           </a:p>
           <a:p>
             <a:r>
-              <a:rPr lang="en-US" sz="1150" b="1" dirty="0"/>
+              <a:rPr lang="en-US" sz="1200" b="1" dirty="0"/>
               <a:t>States: </a:t>
             </a:r>
             <a:r>
               <a:rPr lang="en-US" sz="1200" dirty="0"/>
-              <a:t>The current candidate pool of 5-letter words.</a:t>
-            </a:r>
-          </a:p>
-          <a:p>
+              <a:t>The current candidate pool after each guess </a:t>
+            </a:r>
             <a:r>
               <a:rPr lang="en-US" sz="1200" b="1" dirty="0"/>
               <a:t>Heuristic: </a:t>
             </a:r>
             <a:r>
               <a:rPr lang="en-US" sz="1200" dirty="0"/>
-              <a:t>Sum of </a:t>
-            </a:r>
-            <a:r>
-              <a:rPr lang="en-US" sz="1200" b="1" dirty="0"/>
-              <a:t>unique letter frequencies</a:t>
-            </a:r>
-            <a:r>
-              <a:rPr lang="en-US" sz="1200" dirty="0"/>
-              <a:t>, recomputed with each turn (because the word pool changes).</a:t>
-            </a:r>
-            <a:endParaRPr lang="en-US" sz="1150" b="1" dirty="0"/>
+              <a:t>Sum of letter frequencies at the same position, for all letters of the word</a:t>
+            </a:r>
+            <a:endParaRPr lang="en-US" sz="1200" b="1" dirty="0"/>
           </a:p>
         </p:txBody>
       </p:sp>
@@ -6531,7 +6602,7 @@
                 <a:ea typeface="Georgia" pitchFamily="34" charset="-122"/>
                 <a:cs typeface="Georgia" pitchFamily="34" charset="-120"/>
               </a:rPr>
-              <a:t>✂️  Pruning Candidates</a:t>
+              <a:t>✂️  CSP Aspect</a:t>
             </a:r>
             <a:endParaRPr lang="en-US" sz="1350" dirty="0"/>
           </a:p>
@@ -6539,14 +6610,14 @@
       </p:sp>
       <p:sp>
         <p:nvSpPr>
-          <p:cNvPr id="16" name="Text 14"/>
-          <p:cNvSpPr/>
-          <p:nvPr/>
-        </p:nvSpPr>
-        <p:spPr>
-          <a:xfrm>
-            <a:off x="5010912" y="3419856"/>
-            <a:ext cx="3886200" cy="1115568"/>
+          <p:cNvPr id="17" name="Text 15"/>
+          <p:cNvSpPr/>
+          <p:nvPr/>
+        </p:nvSpPr>
+        <p:spPr>
+          <a:xfrm>
+            <a:off x="274320" y="4773168"/>
+            <a:ext cx="8595360" cy="256032"/>
           </a:xfrm>
           <a:prstGeom prst="rect">
             <a:avLst/>
@@ -6558,170 +6629,84 @@
           <a:bodyPr wrap="square" rtlCol="0" anchor="ctr"/>
           <a:lstStyle/>
           <a:p>
-            <a:pPr marL="0" indent="0">
+            <a:pPr marL="0" indent="0" algn="ctr">
               <a:buNone/>
             </a:pPr>
             <a:r>
-              <a:rPr lang="en-US" sz="1150" b="1" dirty="0">
-                <a:solidFill>
-                  <a:srgbClr val="334155"/>
+              <a:rPr lang="en-US" sz="1050" i="1" dirty="0">
+                <a:solidFill>
+                  <a:srgbClr val="64748B"/>
                 </a:solidFill>
                 <a:latin typeface="Calibri" pitchFamily="34" charset="0"/>
                 <a:ea typeface="Calibri" pitchFamily="34" charset="-122"/>
                 <a:cs typeface="Calibri" pitchFamily="34" charset="-120"/>
               </a:rPr>
-              <a:t>The Hill Climbing Algo:</a:t>
-            </a:r>
-          </a:p>
-          <a:p>
-            <a:pPr marL="0" indent="0">
-              <a:buNone/>
-            </a:pPr>
-            <a:r>
-              <a:rPr lang="en-US" sz="1150" b="1" dirty="0">
-                <a:solidFill>
-                  <a:srgbClr val="334155"/>
-                </a:solidFill>
-                <a:latin typeface="Calibri" pitchFamily="34" charset="0"/>
-                <a:ea typeface="Calibri" pitchFamily="34" charset="-122"/>
-                <a:cs typeface="Calibri" pitchFamily="34" charset="-120"/>
-              </a:rPr>
-              <a:t>Turn 1:   </a:t>
-            </a:r>
-            <a:r>
-              <a:rPr lang="en-US" sz="1150" dirty="0">
-                <a:solidFill>
-                  <a:srgbClr val="334155"/>
-                </a:solidFill>
-                <a:latin typeface="Calibri" pitchFamily="34" charset="0"/>
-                <a:ea typeface="Calibri" pitchFamily="34" charset="-122"/>
-                <a:cs typeface="Calibri" pitchFamily="34" charset="-120"/>
-              </a:rPr>
-              <a:t>2315 	Candidates</a:t>
-            </a:r>
-          </a:p>
-          <a:p>
-            <a:pPr marL="0" indent="0">
-              <a:buNone/>
-            </a:pPr>
-            <a:r>
-              <a:rPr lang="en-US" sz="1150" b="1" dirty="0">
-                <a:solidFill>
-                  <a:srgbClr val="334155"/>
-                </a:solidFill>
-                <a:latin typeface="Calibri" pitchFamily="34" charset="0"/>
-                <a:cs typeface="Calibri" pitchFamily="34" charset="-120"/>
-              </a:rPr>
-              <a:t>Turn 2:   </a:t>
-            </a:r>
-            <a:r>
-              <a:rPr lang="en-US" sz="1150" dirty="0">
-                <a:solidFill>
-                  <a:srgbClr val="334155"/>
-                </a:solidFill>
-                <a:latin typeface="Calibri" pitchFamily="34" charset="0"/>
-                <a:cs typeface="Calibri" pitchFamily="34" charset="-120"/>
-              </a:rPr>
-              <a:t>145     Candidates</a:t>
-            </a:r>
-          </a:p>
-          <a:p>
-            <a:pPr marL="0" indent="0">
-              <a:buNone/>
-            </a:pPr>
-            <a:r>
-              <a:rPr lang="en-US" sz="1150" b="1" dirty="0">
-                <a:solidFill>
-                  <a:srgbClr val="334155"/>
-                </a:solidFill>
-                <a:latin typeface="Calibri" pitchFamily="34" charset="0"/>
-                <a:cs typeface="Calibri" pitchFamily="34" charset="-120"/>
-              </a:rPr>
-              <a:t>Turn 3:   </a:t>
-            </a:r>
-            <a:r>
-              <a:rPr lang="en-US" sz="1150" dirty="0">
-                <a:solidFill>
-                  <a:srgbClr val="334155"/>
-                </a:solidFill>
-                <a:latin typeface="Calibri" pitchFamily="34" charset="0"/>
-                <a:cs typeface="Calibri" pitchFamily="34" charset="-120"/>
-              </a:rPr>
-              <a:t>1         	Candidate!</a:t>
-            </a:r>
-            <a:endParaRPr lang="en-US" sz="1150" dirty="0"/>
-          </a:p>
-        </p:txBody>
-      </p:sp>
-      <p:sp>
-        <p:nvSpPr>
-          <p:cNvPr id="17" name="Text 15"/>
-          <p:cNvSpPr/>
-          <p:nvPr/>
-        </p:nvSpPr>
-        <p:spPr>
-          <a:xfrm>
-            <a:off x="274320" y="4773168"/>
-            <a:ext cx="8595360" cy="256032"/>
-          </a:xfrm>
-          <a:prstGeom prst="rect">
-            <a:avLst/>
-          </a:prstGeom>
-          <a:noFill/>
-          <a:ln/>
-        </p:spPr>
-        <p:txBody>
-          <a:bodyPr wrap="square" rtlCol="0" anchor="ctr"/>
-          <a:lstStyle/>
-          <a:p>
-            <a:pPr marL="0" indent="0" algn="ctr">
-              <a:buNone/>
-            </a:pPr>
-            <a:r>
-              <a:rPr lang="en-US" sz="1050" i="1" dirty="0">
-                <a:solidFill>
-                  <a:srgbClr val="64748B"/>
-                </a:solidFill>
-                <a:latin typeface="Calibri" pitchFamily="34" charset="0"/>
-                <a:ea typeface="Calibri" pitchFamily="34" charset="-122"/>
-                <a:cs typeface="Calibri" pitchFamily="34" charset="-120"/>
-              </a:rPr>
               <a:t>All logic is pure Python</a:t>
             </a:r>
             <a:endParaRPr lang="en-US" sz="1050" dirty="0"/>
           </a:p>
         </p:txBody>
       </p:sp>
-      <p:pic>
-        <p:nvPicPr>
-          <p:cNvPr id="20" name="Picture 19">
+      <p:sp>
+        <p:nvSpPr>
+          <p:cNvPr id="21" name="TextBox 20">
             <a:extLst>
               <a:ext uri="{FF2B5EF4-FFF2-40B4-BE49-F238E27FC236}">
-                <a16:creationId xmlns:a16="http://schemas.microsoft.com/office/drawing/2014/main" id="{7A2C674F-7D4D-041E-C2D5-637371BAA36D}"/>
+                <a16:creationId xmlns:a16="http://schemas.microsoft.com/office/drawing/2014/main" id="{03332DC3-8D46-FD07-C7C4-CC6A72BE20F6}"/>
               </a:ext>
             </a:extLst>
           </p:cNvPr>
-          <p:cNvPicPr>
-            <a:picLocks noChangeAspect="1"/>
-          </p:cNvPicPr>
-          <p:nvPr/>
-        </p:nvPicPr>
-        <p:blipFill>
-          <a:blip r:embed="rId3"/>
-          <a:stretch>
-            <a:fillRect/>
-          </a:stretch>
-        </p:blipFill>
-        <p:spPr>
-          <a:xfrm>
-            <a:off x="6949440" y="3645701"/>
-            <a:ext cx="1622294" cy="682166"/>
-          </a:xfrm>
-          <a:prstGeom prst="rect">
-            <a:avLst/>
-          </a:prstGeom>
-        </p:spPr>
-      </p:pic>
+          <p:cNvSpPr txBox="1"/>
+          <p:nvPr/>
+        </p:nvSpPr>
+        <p:spPr>
+          <a:xfrm>
+            <a:off x="5010912" y="3663618"/>
+            <a:ext cx="3886200" cy="646331"/>
+          </a:xfrm>
+          <a:prstGeom prst="rect">
+            <a:avLst/>
+          </a:prstGeom>
+          <a:noFill/>
+        </p:spPr>
+        <p:txBody>
+          <a:bodyPr wrap="square">
+            <a:spAutoFit/>
+          </a:bodyPr>
+          <a:lstStyle/>
+          <a:p>
+            <a:r>
+              <a:rPr lang="fr-FR" sz="1200" b="1" dirty="0"/>
+              <a:t>Variables:</a:t>
+            </a:r>
+            <a:r>
+              <a:rPr lang="fr-FR" sz="1200" dirty="0"/>
+              <a:t> Position 1, Position 2, … , Position 5</a:t>
+            </a:r>
+          </a:p>
+          <a:p>
+            <a:r>
+              <a:rPr lang="en-US" sz="1200" b="1" dirty="0"/>
+              <a:t>Domains:</a:t>
+            </a:r>
+            <a:r>
+              <a:rPr lang="en-US" sz="1200" dirty="0"/>
+              <a:t> {A -&gt; Z} for each position</a:t>
+            </a:r>
+          </a:p>
+          <a:p>
+            <a:r>
+              <a:rPr lang="en-US" sz="1200" b="1" dirty="0"/>
+              <a:t>Constraints:</a:t>
+            </a:r>
+            <a:r>
+              <a:rPr lang="en-US" sz="1200" dirty="0"/>
+              <a:t> 🟩 🟨 ⬜</a:t>
+            </a:r>
+            <a:endParaRPr lang="en-US" sz="1200" b="1" dirty="0"/>
+          </a:p>
+        </p:txBody>
+      </p:sp>
     </p:spTree>
   </p:cSld>
   <p:clrMapOvr>
@@ -6865,14 +6850,14 @@
           <p:nvPr>
             <p:extLst>
               <p:ext uri="{D42A27DB-BD31-4B8C-83A1-F6EECF244321}">
-                <p14:modId xmlns:p14="http://schemas.microsoft.com/office/powerpoint/2010/main" val="518794352"/>
+                <p14:modId xmlns:p14="http://schemas.microsoft.com/office/powerpoint/2010/main" val="4066444748"/>
               </p:ext>
             </p:extLst>
           </p:nvPr>
         </p:nvGraphicFramePr>
         <p:xfrm>
           <a:off x="274320" y="914400"/>
-          <a:ext cx="5303520" cy="3474720"/>
+          <a:ext cx="5303520" cy="3995334"/>
         </p:xfrm>
         <a:graphic>
           <a:graphicData uri="http://schemas.openxmlformats.org/drawingml/2006/chart">
@@ -6889,7 +6874,7 @@
         <p:spPr>
           <a:xfrm>
             <a:off x="5852160" y="960120"/>
-            <a:ext cx="3017520" cy="1078992"/>
+            <a:ext cx="3017520" cy="1783080"/>
           </a:xfrm>
           <a:prstGeom prst="rect">
             <a:avLst/>
@@ -6927,8 +6912,8 @@
         </p:nvSpPr>
         <p:spPr>
           <a:xfrm>
-            <a:off x="5989320" y="1033272"/>
-            <a:ext cx="2743200" cy="530352"/>
+            <a:off x="5989320" y="1251415"/>
+            <a:ext cx="2743200" cy="876429"/>
           </a:xfrm>
           <a:prstGeom prst="rect">
             <a:avLst/>
@@ -6952,7 +6937,7 @@
                 <a:ea typeface="Georgia" pitchFamily="34" charset="-122"/>
                 <a:cs typeface="Georgia" pitchFamily="34" charset="-120"/>
               </a:rPr>
-              <a:t>3.647</a:t>
+              <a:t>3.626</a:t>
             </a:r>
             <a:endParaRPr lang="en-US" sz="3200" dirty="0"/>
           </a:p>
@@ -6966,8 +6951,8 @@
         </p:nvSpPr>
         <p:spPr>
           <a:xfrm>
-            <a:off x="5989320" y="1581912"/>
-            <a:ext cx="2743200" cy="347472"/>
+            <a:off x="5989320" y="1800056"/>
+            <a:ext cx="2743200" cy="574212"/>
           </a:xfrm>
           <a:prstGeom prst="rect">
             <a:avLst/>
@@ -6991,7 +6976,7 @@
                 <a:ea typeface="Calibri" pitchFamily="34" charset="-122"/>
                 <a:cs typeface="Calibri" pitchFamily="34" charset="-120"/>
               </a:rPr>
-              <a:t>Bot Avg — turns to solve</a:t>
+              <a:t>Bot Avg = turns to solve</a:t>
             </a:r>
             <a:endParaRPr lang="en-US" sz="1100" dirty="0"/>
           </a:p>
@@ -7005,8 +6990,8 @@
         </p:nvSpPr>
         <p:spPr>
           <a:xfrm>
-            <a:off x="5852160" y="2221992"/>
-            <a:ext cx="3017520" cy="1078992"/>
+            <a:off x="5852160" y="2912067"/>
+            <a:ext cx="3017520" cy="1783080"/>
           </a:xfrm>
           <a:prstGeom prst="rect">
             <a:avLst/>
@@ -7044,8 +7029,8 @@
         </p:nvSpPr>
         <p:spPr>
           <a:xfrm>
-            <a:off x="5989320" y="2295144"/>
-            <a:ext cx="2743200" cy="530352"/>
+            <a:off x="5989320" y="3166702"/>
+            <a:ext cx="2743200" cy="876429"/>
           </a:xfrm>
           <a:prstGeom prst="rect">
             <a:avLst/>
@@ -7069,7 +7054,7 @@
                 <a:ea typeface="Georgia" pitchFamily="34" charset="-122"/>
                 <a:cs typeface="Georgia" pitchFamily="34" charset="-120"/>
               </a:rPr>
-              <a:t>99%</a:t>
+              <a:t>100%</a:t>
             </a:r>
             <a:endParaRPr lang="en-US" sz="3200" dirty="0"/>
           </a:p>
@@ -7083,8 +7068,8 @@
         </p:nvSpPr>
         <p:spPr>
           <a:xfrm>
-            <a:off x="5989320" y="2843784"/>
-            <a:ext cx="2743200" cy="347472"/>
+            <a:off x="5989320" y="3715343"/>
+            <a:ext cx="2743200" cy="574212"/>
           </a:xfrm>
           <a:prstGeom prst="rect">
             <a:avLst/>
@@ -7108,163 +7093,7 @@
                 <a:ea typeface="Calibri" pitchFamily="34" charset="-122"/>
                 <a:cs typeface="Calibri" pitchFamily="34" charset="-120"/>
               </a:rPr>
-              <a:t>Solve Rate — across all words</a:t>
-            </a:r>
-            <a:endParaRPr lang="en-US" sz="1100" dirty="0"/>
-          </a:p>
-        </p:txBody>
-      </p:sp>
-      <p:sp>
-        <p:nvSpPr>
-          <p:cNvPr id="12" name="Shape 9"/>
-          <p:cNvSpPr/>
-          <p:nvPr/>
-        </p:nvSpPr>
-        <p:spPr>
-          <a:xfrm>
-            <a:off x="5852160" y="3483864"/>
-            <a:ext cx="3017520" cy="1078992"/>
-          </a:xfrm>
-          <a:prstGeom prst="rect">
-            <a:avLst/>
-          </a:prstGeom>
-          <a:solidFill>
-            <a:srgbClr val="1B2A4A"/>
-          </a:solidFill>
-          <a:ln w="12700">
-            <a:solidFill>
-              <a:srgbClr val="E2E8F0"/>
-            </a:solidFill>
-            <a:prstDash val="solid"/>
-          </a:ln>
-          <a:effectLst>
-            <a:outerShdw blurRad="101600" dist="38100" dir="8100000" algn="bl" rotWithShape="0">
-              <a:srgbClr val="000000">
-                <a:alpha val="12000"/>
-              </a:srgbClr>
-            </a:outerShdw>
-          </a:effectLst>
-        </p:spPr>
-        <p:txBody>
-          <a:bodyPr/>
-          <a:lstStyle/>
-          <a:p>
-            <a:endParaRPr lang="en-US"/>
-          </a:p>
-        </p:txBody>
-      </p:sp>
-      <p:sp>
-        <p:nvSpPr>
-          <p:cNvPr id="13" name="Text 10"/>
-          <p:cNvSpPr/>
-          <p:nvPr/>
-        </p:nvSpPr>
-        <p:spPr>
-          <a:xfrm>
-            <a:off x="5989320" y="3557016"/>
-            <a:ext cx="2743200" cy="530352"/>
-          </a:xfrm>
-          <a:prstGeom prst="rect">
-            <a:avLst/>
-          </a:prstGeom>
-          <a:noFill/>
-          <a:ln/>
-        </p:spPr>
-        <p:txBody>
-          <a:bodyPr wrap="square" lIns="0" tIns="0" rIns="0" bIns="0" rtlCol="0" anchor="ctr"/>
-          <a:lstStyle/>
-          <a:p>
-            <a:pPr marL="0" indent="0" algn="ctr">
-              <a:buNone/>
-            </a:pPr>
-            <a:r>
-              <a:rPr lang="en-US" sz="3200" b="1" dirty="0">
-                <a:solidFill>
-                  <a:srgbClr val="5EEAD4"/>
-                </a:solidFill>
-                <a:latin typeface="Georgia" pitchFamily="34" charset="0"/>
-                <a:ea typeface="Georgia" pitchFamily="34" charset="-122"/>
-                <a:cs typeface="Georgia" pitchFamily="34" charset="-120"/>
-              </a:rPr>
-              <a:t>22</a:t>
-            </a:r>
-            <a:endParaRPr lang="en-US" sz="3200" dirty="0"/>
-          </a:p>
-        </p:txBody>
-      </p:sp>
-      <p:sp>
-        <p:nvSpPr>
-          <p:cNvPr id="14" name="Text 11"/>
-          <p:cNvSpPr/>
-          <p:nvPr/>
-        </p:nvSpPr>
-        <p:spPr>
-          <a:xfrm>
-            <a:off x="5989320" y="4105656"/>
-            <a:ext cx="2743200" cy="347472"/>
-          </a:xfrm>
-          <a:prstGeom prst="rect">
-            <a:avLst/>
-          </a:prstGeom>
-          <a:noFill/>
-          <a:ln/>
-        </p:spPr>
-        <p:txBody>
-          <a:bodyPr wrap="square" lIns="0" tIns="0" rIns="0" bIns="0" rtlCol="0" anchor="ctr"/>
-          <a:lstStyle/>
-          <a:p>
-            <a:pPr marL="0" indent="0" algn="ctr">
-              <a:buNone/>
-            </a:pPr>
-            <a:r>
-              <a:rPr lang="en-US" sz="1100" dirty="0">
-                <a:solidFill>
-                  <a:srgbClr val="FFFFFF"/>
-                </a:solidFill>
-                <a:latin typeface="Calibri" pitchFamily="34" charset="0"/>
-                <a:ea typeface="Calibri" pitchFamily="34" charset="-122"/>
-                <a:cs typeface="Calibri" pitchFamily="34" charset="-120"/>
-              </a:rPr>
-              <a:t>Failures — out of all ~2,315 words</a:t>
-            </a:r>
-            <a:endParaRPr lang="en-US" sz="1100" dirty="0"/>
-          </a:p>
-        </p:txBody>
-      </p:sp>
-      <p:sp>
-        <p:nvSpPr>
-          <p:cNvPr id="15" name="Text 12"/>
-          <p:cNvSpPr/>
-          <p:nvPr/>
-        </p:nvSpPr>
-        <p:spPr>
-          <a:xfrm>
-            <a:off x="274320" y="4544568"/>
-            <a:ext cx="8595360" cy="347472"/>
-          </a:xfrm>
-          <a:prstGeom prst="rect">
-            <a:avLst/>
-          </a:prstGeom>
-          <a:noFill/>
-          <a:ln/>
-        </p:spPr>
-        <p:txBody>
-          <a:bodyPr wrap="square" rtlCol="0" anchor="ctr"/>
-          <a:lstStyle/>
-          <a:p>
-            <a:pPr marL="0" indent="0" algn="ctr">
-              <a:buNone/>
-            </a:pPr>
-            <a:r>
-              <a:rPr lang="en-US" sz="1100" i="1" dirty="0">
-                <a:solidFill>
-                  <a:srgbClr val="64748B"/>
-                </a:solidFill>
-                <a:latin typeface="Calibri" pitchFamily="34" charset="0"/>
-                <a:ea typeface="Calibri" pitchFamily="34" charset="-122"/>
-                <a:cs typeface="Calibri" pitchFamily="34" charset="-120"/>
-              </a:rPr>
-              <a:t>These rare failures occur on words differing only in one letter.</a:t>
+              <a:t>Solve Rate across all words</a:t>
             </a:r>
             <a:endParaRPr lang="en-US" sz="1100" dirty="0"/>
           </a:p>
@@ -7305,6 +7134,45 @@
       </p:grpSpPr>
       <p:sp>
         <p:nvSpPr>
+          <p:cNvPr id="12" name="Shape 9"/>
+          <p:cNvSpPr/>
+          <p:nvPr/>
+        </p:nvSpPr>
+        <p:spPr>
+          <a:xfrm>
+            <a:off x="6126480" y="3794760"/>
+            <a:ext cx="2697480" cy="1115568"/>
+          </a:xfrm>
+          <a:prstGeom prst="rect">
+            <a:avLst/>
+          </a:prstGeom>
+          <a:solidFill>
+            <a:srgbClr val="FFFFFF"/>
+          </a:solidFill>
+          <a:ln w="12700">
+            <a:solidFill>
+              <a:srgbClr val="E2E8F0"/>
+            </a:solidFill>
+            <a:prstDash val="solid"/>
+          </a:ln>
+          <a:effectLst>
+            <a:outerShdw blurRad="101600" dist="38100" dir="8100000" algn="bl" rotWithShape="0">
+              <a:srgbClr val="000000">
+                <a:alpha val="12000"/>
+              </a:srgbClr>
+            </a:outerShdw>
+          </a:effectLst>
+        </p:spPr>
+        <p:txBody>
+          <a:bodyPr/>
+          <a:lstStyle/>
+          <a:p>
+            <a:endParaRPr lang="en-US"/>
+          </a:p>
+        </p:txBody>
+      </p:sp>
+      <p:sp>
+        <p:nvSpPr>
           <p:cNvPr id="2" name="Shape 0"/>
           <p:cNvSpPr/>
           <p:nvPr/>
@@ -7415,7 +7283,7 @@
           <p:nvPr>
             <p:extLst>
               <p:ext uri="{D42A27DB-BD31-4B8C-83A1-F6EECF244321}">
-                <p14:modId xmlns:p14="http://schemas.microsoft.com/office/powerpoint/2010/main" val="276293549"/>
+                <p14:modId xmlns:p14="http://schemas.microsoft.com/office/powerpoint/2010/main" val="1906819217"/>
               </p:ext>
             </p:extLst>
           </p:nvPr>
@@ -7612,7 +7480,7 @@
                           <a:ea typeface="Calibri" pitchFamily="34" charset="-122"/>
                           <a:cs typeface="Calibri" pitchFamily="34" charset="-120"/>
                         </a:rPr>
-                        <a:t>Hill Climbing</a:t>
+                        <a:t>Our Bot</a:t>
                       </a:r>
                       <a:endParaRPr lang="en-US" sz="1300" dirty="0">
                         <a:latin typeface="Calibri" charset="0"/>
@@ -7680,7 +7548,7 @@
                           <a:ea typeface="Calibri" pitchFamily="34" charset="-122"/>
                           <a:cs typeface="Calibri" pitchFamily="34" charset="-120"/>
                         </a:rPr>
-                        <a:t>Human (Hamza)</a:t>
+                        <a:t>Average Human</a:t>
                       </a:r>
                       <a:endParaRPr lang="en-US" sz="1300" dirty="0">
                         <a:latin typeface="Calibri" charset="0"/>
@@ -7888,7 +7756,7 @@
                           <a:ea typeface="Calibri" pitchFamily="34" charset="-122"/>
                           <a:cs typeface="Calibri" pitchFamily="34" charset="-120"/>
                         </a:rPr>
-                        <a:t>3.647</a:t>
+                        <a:t>3.626</a:t>
                       </a:r>
                       <a:endParaRPr lang="en-US" sz="1300" dirty="0">
                         <a:latin typeface="Calibri" charset="0"/>
@@ -7953,7 +7821,7 @@
                           <a:ea typeface="Calibri" pitchFamily="34" charset="-122"/>
                           <a:cs typeface="Calibri" pitchFamily="34" charset="-120"/>
                         </a:rPr>
-                        <a:t>4.113</a:t>
+                        <a:t>3.813</a:t>
                       </a:r>
                       <a:endParaRPr lang="en-US" sz="1300" dirty="0">
                         <a:latin typeface="Calibri" charset="0"/>
@@ -8158,7 +8026,7 @@
                           <a:ea typeface="Calibri" pitchFamily="34" charset="-122"/>
                           <a:cs typeface="Calibri" pitchFamily="34" charset="-120"/>
                         </a:rPr>
-                        <a:t>0.847</a:t>
+                        <a:t>0.8054</a:t>
                       </a:r>
                       <a:endParaRPr lang="en-US" sz="1300" dirty="0">
                         <a:latin typeface="Calibri" charset="0"/>
@@ -8223,7 +8091,7 @@
                           <a:ea typeface="Calibri" pitchFamily="34" charset="-122"/>
                           <a:cs typeface="Calibri" pitchFamily="34" charset="-120"/>
                         </a:rPr>
-                        <a:t>1.078</a:t>
+                        <a:t>1.143</a:t>
                       </a:r>
                       <a:endParaRPr lang="en-US" sz="1300" dirty="0">
                         <a:latin typeface="Calibri" charset="0"/>
@@ -8428,7 +8296,7 @@
                           <a:ea typeface="Calibri" pitchFamily="34" charset="-122"/>
                           <a:cs typeface="Calibri" pitchFamily="34" charset="-120"/>
                         </a:rPr>
-                        <a:t>1.0%</a:t>
+                        <a:t>0%</a:t>
                       </a:r>
                       <a:endParaRPr lang="en-US" sz="1300" dirty="0">
                         <a:latin typeface="Calibri" charset="0"/>
@@ -8493,7 +8361,7 @@
                           <a:ea typeface="Calibri" pitchFamily="34" charset="-122"/>
                           <a:cs typeface="Calibri" pitchFamily="34" charset="-120"/>
                         </a:rPr>
-                        <a:t>4.5%</a:t>
+                        <a:t>1.5%</a:t>
                       </a:r>
                       <a:endParaRPr lang="en-US" sz="1300" dirty="0">
                         <a:latin typeface="Calibri" charset="0"/>
@@ -8659,7 +8527,7 @@
                 <a:ea typeface="Calibri" pitchFamily="34" charset="-122"/>
                 <a:cs typeface="Calibri" pitchFamily="34" charset="-120"/>
               </a:rPr>
-              <a:t>The Solved Bot is the Optimal Method to play Wordle found by Alex Selby in 2022, so its numbers were used a benchmark.</a:t>
+              <a:t>The Solved Bot is the Optimal Method to play Wordle found by Alex Selby in 2022, so it was used a benchmark.</a:t>
             </a:r>
             <a:endParaRPr lang="en-US" sz="1000" dirty="0"/>
           </a:p>
@@ -8748,7 +8616,7 @@
         </p:nvSpPr>
         <p:spPr>
           <a:xfrm>
-            <a:off x="3337560" y="4343400"/>
+            <a:off x="6217920" y="4343400"/>
             <a:ext cx="2514600" cy="530352"/>
           </a:xfrm>
           <a:prstGeom prst="rect">
@@ -8761,59 +8629,10 @@
           <a:bodyPr wrap="square" rtlCol="0" anchor="ctr"/>
           <a:lstStyle/>
           <a:p>
-            <a:pPr marL="0" indent="0">
-              <a:buNone/>
-            </a:pPr>
-            <a:r>
-              <a:rPr lang="en-US" sz="1000" dirty="0">
-                <a:solidFill>
-                  <a:srgbClr val="334155"/>
-                </a:solidFill>
-                <a:latin typeface="Calibri" pitchFamily="34" charset="0"/>
-                <a:cs typeface="Calibri" pitchFamily="34" charset="-120"/>
-              </a:rPr>
-              <a:t>Although the Hill Climbing Algorithm fails to beat all wordles, it still beats humans by 3.5%</a:t>
-            </a:r>
-            <a:endParaRPr lang="en-US" sz="1000" dirty="0"/>
-          </a:p>
-        </p:txBody>
-      </p:sp>
-      <p:sp>
-        <p:nvSpPr>
-          <p:cNvPr id="12" name="Shape 9"/>
-          <p:cNvSpPr/>
-          <p:nvPr/>
-        </p:nvSpPr>
-        <p:spPr>
-          <a:xfrm>
-            <a:off x="6126480" y="3794760"/>
-            <a:ext cx="2697480" cy="1115568"/>
-          </a:xfrm>
-          <a:prstGeom prst="rect">
-            <a:avLst/>
-          </a:prstGeom>
-          <a:solidFill>
-            <a:srgbClr val="FFFFFF"/>
-          </a:solidFill>
-          <a:ln w="12700">
-            <a:solidFill>
-              <a:srgbClr val="E2E8F0"/>
-            </a:solidFill>
-            <a:prstDash val="solid"/>
-          </a:ln>
-          <a:effectLst>
-            <a:outerShdw blurRad="101600" dist="38100" dir="8100000" algn="bl" rotWithShape="0">
-              <a:srgbClr val="000000">
-                <a:alpha val="12000"/>
-              </a:srgbClr>
-            </a:outerShdw>
-          </a:effectLst>
-        </p:spPr>
-        <p:txBody>
-          <a:bodyPr/>
-          <a:lstStyle/>
-          <a:p>
-            <a:endParaRPr lang="en-US"/>
+            <a:r>
+              <a:rPr lang="en-US" sz="1000" dirty="0"/>
+              <a:t>The Our Bot uses 6% more turns than the optimal bot but uses 4.9% less than a human player.</a:t>
+            </a:r>
           </a:p>
         </p:txBody>
       </p:sp>
@@ -8861,7 +8680,7 @@
         </p:nvSpPr>
         <p:spPr>
           <a:xfrm>
-            <a:off x="6217920" y="4343400"/>
+            <a:off x="3337560" y="4343400"/>
             <a:ext cx="2514600" cy="530352"/>
           </a:xfrm>
           <a:prstGeom prst="rect">
@@ -8886,7 +8705,7 @@
                 <a:ea typeface="Calibri" pitchFamily="34" charset="-122"/>
                 <a:cs typeface="Calibri" pitchFamily="34" charset="-120"/>
               </a:rPr>
-              <a:t>Hill Climbing’s consistency (Std Dev) lies right between human and optimal, which may come from its greedy nature.</a:t>
+              <a:t>Our Bot’s consistency (Std Dev) lies right between human and optimal, which may come from its greedy nature.</a:t>
             </a:r>
             <a:endParaRPr lang="en-US" sz="1000" dirty="0"/>
           </a:p>
@@ -9132,7 +8951,7 @@
                 <a:ea typeface="Calibri" pitchFamily="34" charset="-122"/>
                 <a:cs typeface="Calibri" pitchFamily="34" charset="-120"/>
               </a:rPr>
-              <a:t>The greedy hill-climbing solver solves the full word list with a 99% success rate with an average 3.647 turns needed to solve.</a:t>
+              <a:t>Our hill-climbing solver solves the full word list with a 100% success rate with an average 3.626 turns needed to solve.</a:t>
             </a:r>
             <a:endParaRPr lang="en-US" sz="1100" dirty="0"/>
           </a:p>
@@ -9230,9 +9049,6 @@
           <a:bodyPr wrap="square" rtlCol="0" anchor="ctr"/>
           <a:lstStyle/>
           <a:p>
-            <a:pPr marL="0" indent="0">
-              <a:buNone/>
-            </a:pPr>
             <a:r>
               <a:rPr lang="en-US" sz="1100" dirty="0">
                 <a:solidFill>
@@ -9242,7 +9058,7 @@
                 <a:ea typeface="Calibri" pitchFamily="34" charset="-122"/>
                 <a:cs typeface="Calibri" pitchFamily="34" charset="-120"/>
               </a:rPr>
-              <a:t>The pruning process is essential to the function of this AI, decreasing time on frequency recomputation, and ensures that each subsequent climb focuses only on valid candidates</a:t>
+              <a:t>The pruning process that comes from CSP is essential to the function of this AI, ensuring that each subsequent climb focuses only on valid candidates, and decreasing computing time with each turn.</a:t>
             </a:r>
             <a:endParaRPr lang="en-US" sz="1100" dirty="0"/>
           </a:p>
@@ -9352,7 +9168,7 @@
                 <a:ea typeface="Calibri" pitchFamily="34" charset="-122"/>
                 <a:cs typeface="Calibri" pitchFamily="34" charset="-120"/>
               </a:rPr>
-              <a:t>With a mean of 3.48 turns and 0% failure rate, the solver consistently beats both tracked human play (3.65) and the general population mean (4.11).</a:t>
+              <a:t>The Bot takes 11.8% less turns than a human (Hamza), and is more consistent beating the Wordle, both in terms of failure rate &amp; Std Dev</a:t>
             </a:r>
             <a:endParaRPr lang="en-US" sz="1100" dirty="0"/>
           </a:p>
@@ -9423,7 +9239,7 @@
                 <a:ea typeface="Calibri" pitchFamily="34" charset="-122"/>
                 <a:cs typeface="Calibri" pitchFamily="34" charset="-120"/>
               </a:rPr>
-              <a:t>Greedy Hill Climbing · Wordle Solver · Human vs AI</a:t>
+              <a:t>Wordle Solver · Human vs AI</a:t>
             </a:r>
             <a:endParaRPr lang="en-US" sz="1100" dirty="0"/>
           </a:p>

</xml_diff>